<commit_message>
fixed few issue when we upload new document
</commit_message>
<xml_diff>
--- a/docs/hackathon_demo_deck.pptx
+++ b/docs/hackathon_demo_deck.pptx
@@ -5,17 +5,17 @@
     <p:sldMasterId id="2147483648" r:id="rId1"/>
   </p:sldMasterIdLst>
   <p:sldIdLst>
-    <p:sldId id="256" r:id="rId7"/>
-    <p:sldId id="257" r:id="rId8"/>
-    <p:sldId id="258" r:id="rId9"/>
-    <p:sldId id="259" r:id="rId10"/>
-    <p:sldId id="260" r:id="rId11"/>
-    <p:sldId id="261" r:id="rId12"/>
-    <p:sldId id="262" r:id="rId13"/>
-    <p:sldId id="263" r:id="rId14"/>
-    <p:sldId id="264" r:id="rId15"/>
+    <p:sldId id="256" r:id="rId2"/>
+    <p:sldId id="257" r:id="rId3"/>
+    <p:sldId id="258" r:id="rId4"/>
+    <p:sldId id="259" r:id="rId5"/>
+    <p:sldId id="260" r:id="rId6"/>
+    <p:sldId id="261" r:id="rId7"/>
+    <p:sldId id="262" r:id="rId8"/>
+    <p:sldId id="263" r:id="rId9"/>
+    <p:sldId id="264" r:id="rId10"/>
   </p:sldIdLst>
-  <p:sldSz cx="12188952" cy="6858000" type="screen4x3"/>
+  <p:sldSz cx="12188825" cy="6858000"/>
   <p:notesSz cx="6858000" cy="9144000"/>
   <p:defaultTextStyle>
     <a:defPPr>
@@ -112,6 +112,22 @@
       </a:defRPr>
     </a:lvl9pPr>
   </p:defaultTextStyle>
+  <p:extLst>
+    <p:ext uri="{EFAFB233-063F-42B5-8137-9DF3F51BA10A}">
+      <p15:sldGuideLst xmlns:p15="http://schemas.microsoft.com/office/powerpoint/2012/main">
+        <p15:guide id="1" orient="horz" pos="2160">
+          <p15:clr>
+            <a:srgbClr val="A4A3A4"/>
+          </p15:clr>
+        </p15:guide>
+        <p15:guide id="2" pos="2880">
+          <p15:clr>
+            <a:srgbClr val="A4A3A4"/>
+          </p15:clr>
+        </p15:guide>
+      </p15:sldGuideLst>
+    </p:ext>
+  </p:extLst>
 </p:presentation>
 </file>
 
@@ -153,10 +169,9 @@
           <a:lstStyle/>
           <a:p>
             <a:r>
-              <a:rPr lang="en-US" smtClean="0"/>
+              <a:rPr lang="en-US"/>
               <a:t>Click to edit Master title style</a:t>
             </a:r>
-            <a:endParaRPr lang="en-US"/>
           </a:p>
         </p:txBody>
       </p:sp>
@@ -272,10 +287,9 @@
           </a:lstStyle>
           <a:p>
             <a:r>
-              <a:rPr lang="en-US" smtClean="0"/>
+              <a:rPr lang="en-US"/>
               <a:t>Click to edit Master subtitle style</a:t>
             </a:r>
-            <a:endParaRPr lang="en-US"/>
           </a:p>
         </p:txBody>
       </p:sp>
@@ -296,7 +310,7 @@
           <a:p>
             <a:fld id="{5BCAD085-E8A6-8845-BD4E-CB4CCA059FC4}" type="datetimeFigureOut">
               <a:rPr lang="en-US" smtClean="0"/>
-              <a:t>1/27/13</a:t>
+              <a:t>6/3/2026</a:t>
             </a:fld>
             <a:endParaRPr lang="en-US"/>
           </a:p>
@@ -390,10 +404,9 @@
           <a:lstStyle/>
           <a:p>
             <a:r>
-              <a:rPr lang="en-US" smtClean="0"/>
+              <a:rPr lang="en-US"/>
               <a:t>Click to edit Master title style</a:t>
             </a:r>
-            <a:endParaRPr lang="en-US"/>
           </a:p>
         </p:txBody>
       </p:sp>
@@ -414,38 +427,37 @@
           <a:p>
             <a:pPr lvl="0"/>
             <a:r>
-              <a:rPr lang="en-US" smtClean="0"/>
+              <a:rPr lang="en-US"/>
               <a:t>Click to edit Master text styles</a:t>
             </a:r>
           </a:p>
           <a:p>
             <a:pPr lvl="1"/>
             <a:r>
-              <a:rPr lang="en-US" smtClean="0"/>
+              <a:rPr lang="en-US"/>
               <a:t>Second level</a:t>
             </a:r>
           </a:p>
           <a:p>
             <a:pPr lvl="2"/>
             <a:r>
-              <a:rPr lang="en-US" smtClean="0"/>
+              <a:rPr lang="en-US"/>
               <a:t>Third level</a:t>
             </a:r>
           </a:p>
           <a:p>
             <a:pPr lvl="3"/>
             <a:r>
-              <a:rPr lang="en-US" smtClean="0"/>
+              <a:rPr lang="en-US"/>
               <a:t>Fourth level</a:t>
             </a:r>
           </a:p>
           <a:p>
             <a:pPr lvl="4"/>
             <a:r>
-              <a:rPr lang="en-US" smtClean="0"/>
+              <a:rPr lang="en-US"/>
               <a:t>Fifth level</a:t>
             </a:r>
-            <a:endParaRPr lang="en-US"/>
           </a:p>
         </p:txBody>
       </p:sp>
@@ -466,7 +478,7 @@
           <a:p>
             <a:fld id="{5BCAD085-E8A6-8845-BD4E-CB4CCA059FC4}" type="datetimeFigureOut">
               <a:rPr lang="en-US" smtClean="0"/>
-              <a:t>1/27/13</a:t>
+              <a:t>6/3/2026</a:t>
             </a:fld>
             <a:endParaRPr lang="en-US"/>
           </a:p>
@@ -565,10 +577,9 @@
           <a:lstStyle/>
           <a:p>
             <a:r>
-              <a:rPr lang="en-US" smtClean="0"/>
+              <a:rPr lang="en-US"/>
               <a:t>Click to edit Master title style</a:t>
             </a:r>
-            <a:endParaRPr lang="en-US"/>
           </a:p>
         </p:txBody>
       </p:sp>
@@ -594,38 +605,37 @@
           <a:p>
             <a:pPr lvl="0"/>
             <a:r>
-              <a:rPr lang="en-US" smtClean="0"/>
+              <a:rPr lang="en-US"/>
               <a:t>Click to edit Master text styles</a:t>
             </a:r>
           </a:p>
           <a:p>
             <a:pPr lvl="1"/>
             <a:r>
-              <a:rPr lang="en-US" smtClean="0"/>
+              <a:rPr lang="en-US"/>
               <a:t>Second level</a:t>
             </a:r>
           </a:p>
           <a:p>
             <a:pPr lvl="2"/>
             <a:r>
-              <a:rPr lang="en-US" smtClean="0"/>
+              <a:rPr lang="en-US"/>
               <a:t>Third level</a:t>
             </a:r>
           </a:p>
           <a:p>
             <a:pPr lvl="3"/>
             <a:r>
-              <a:rPr lang="en-US" smtClean="0"/>
+              <a:rPr lang="en-US"/>
               <a:t>Fourth level</a:t>
             </a:r>
           </a:p>
           <a:p>
             <a:pPr lvl="4"/>
             <a:r>
-              <a:rPr lang="en-US" smtClean="0"/>
+              <a:rPr lang="en-US"/>
               <a:t>Fifth level</a:t>
             </a:r>
-            <a:endParaRPr lang="en-US"/>
           </a:p>
         </p:txBody>
       </p:sp>
@@ -646,7 +656,7 @@
           <a:p>
             <a:fld id="{5BCAD085-E8A6-8845-BD4E-CB4CCA059FC4}" type="datetimeFigureOut">
               <a:rPr lang="en-US" smtClean="0"/>
-              <a:t>1/27/13</a:t>
+              <a:t>6/3/2026</a:t>
             </a:fld>
             <a:endParaRPr lang="en-US"/>
           </a:p>
@@ -740,10 +750,9 @@
           <a:lstStyle/>
           <a:p>
             <a:r>
-              <a:rPr lang="en-US" smtClean="0"/>
+              <a:rPr lang="en-US"/>
               <a:t>Click to edit Master title style</a:t>
             </a:r>
-            <a:endParaRPr lang="en-US"/>
           </a:p>
         </p:txBody>
       </p:sp>
@@ -764,38 +773,37 @@
           <a:p>
             <a:pPr lvl="0"/>
             <a:r>
-              <a:rPr lang="en-US" smtClean="0"/>
+              <a:rPr lang="en-US"/>
               <a:t>Click to edit Master text styles</a:t>
             </a:r>
           </a:p>
           <a:p>
             <a:pPr lvl="1"/>
             <a:r>
-              <a:rPr lang="en-US" smtClean="0"/>
+              <a:rPr lang="en-US"/>
               <a:t>Second level</a:t>
             </a:r>
           </a:p>
           <a:p>
             <a:pPr lvl="2"/>
             <a:r>
-              <a:rPr lang="en-US" smtClean="0"/>
+              <a:rPr lang="en-US"/>
               <a:t>Third level</a:t>
             </a:r>
           </a:p>
           <a:p>
             <a:pPr lvl="3"/>
             <a:r>
-              <a:rPr lang="en-US" smtClean="0"/>
+              <a:rPr lang="en-US"/>
               <a:t>Fourth level</a:t>
             </a:r>
           </a:p>
           <a:p>
             <a:pPr lvl="4"/>
             <a:r>
-              <a:rPr lang="en-US" smtClean="0"/>
+              <a:rPr lang="en-US"/>
               <a:t>Fifth level</a:t>
             </a:r>
-            <a:endParaRPr lang="en-US"/>
           </a:p>
         </p:txBody>
       </p:sp>
@@ -816,7 +824,7 @@
           <a:p>
             <a:fld id="{5BCAD085-E8A6-8845-BD4E-CB4CCA059FC4}" type="datetimeFigureOut">
               <a:rPr lang="en-US" smtClean="0"/>
-              <a:t>1/27/13</a:t>
+              <a:t>6/3/2026</a:t>
             </a:fld>
             <a:endParaRPr lang="en-US"/>
           </a:p>
@@ -919,10 +927,9 @@
           </a:lstStyle>
           <a:p>
             <a:r>
-              <a:rPr lang="en-US" smtClean="0"/>
+              <a:rPr lang="en-US"/>
               <a:t>Click to edit Master title style</a:t>
             </a:r>
-            <a:endParaRPr lang="en-US"/>
           </a:p>
         </p:txBody>
       </p:sp>
@@ -1039,7 +1046,7 @@
           <a:p>
             <a:pPr lvl="0"/>
             <a:r>
-              <a:rPr lang="en-US" smtClean="0"/>
+              <a:rPr lang="en-US"/>
               <a:t>Click to edit Master text styles</a:t>
             </a:r>
           </a:p>
@@ -1062,7 +1069,7 @@
           <a:p>
             <a:fld id="{5BCAD085-E8A6-8845-BD4E-CB4CCA059FC4}" type="datetimeFigureOut">
               <a:rPr lang="en-US" smtClean="0"/>
-              <a:t>1/27/13</a:t>
+              <a:t>6/3/2026</a:t>
             </a:fld>
             <a:endParaRPr lang="en-US"/>
           </a:p>
@@ -1156,10 +1163,9 @@
           <a:lstStyle/>
           <a:p>
             <a:r>
-              <a:rPr lang="en-US" smtClean="0"/>
+              <a:rPr lang="en-US"/>
               <a:t>Click to edit Master title style</a:t>
             </a:r>
-            <a:endParaRPr lang="en-US"/>
           </a:p>
         </p:txBody>
       </p:sp>
@@ -1213,38 +1219,37 @@
           <a:p>
             <a:pPr lvl="0"/>
             <a:r>
-              <a:rPr lang="en-US" smtClean="0"/>
+              <a:rPr lang="en-US"/>
               <a:t>Click to edit Master text styles</a:t>
             </a:r>
           </a:p>
           <a:p>
             <a:pPr lvl="1"/>
             <a:r>
-              <a:rPr lang="en-US" smtClean="0"/>
+              <a:rPr lang="en-US"/>
               <a:t>Second level</a:t>
             </a:r>
           </a:p>
           <a:p>
             <a:pPr lvl="2"/>
             <a:r>
-              <a:rPr lang="en-US" smtClean="0"/>
+              <a:rPr lang="en-US"/>
               <a:t>Third level</a:t>
             </a:r>
           </a:p>
           <a:p>
             <a:pPr lvl="3"/>
             <a:r>
-              <a:rPr lang="en-US" smtClean="0"/>
+              <a:rPr lang="en-US"/>
               <a:t>Fourth level</a:t>
             </a:r>
           </a:p>
           <a:p>
             <a:pPr lvl="4"/>
             <a:r>
-              <a:rPr lang="en-US" smtClean="0"/>
+              <a:rPr lang="en-US"/>
               <a:t>Fifth level</a:t>
             </a:r>
-            <a:endParaRPr lang="en-US"/>
           </a:p>
         </p:txBody>
       </p:sp>
@@ -1298,38 +1303,37 @@
           <a:p>
             <a:pPr lvl="0"/>
             <a:r>
-              <a:rPr lang="en-US" smtClean="0"/>
+              <a:rPr lang="en-US"/>
               <a:t>Click to edit Master text styles</a:t>
             </a:r>
           </a:p>
           <a:p>
             <a:pPr lvl="1"/>
             <a:r>
-              <a:rPr lang="en-US" smtClean="0"/>
+              <a:rPr lang="en-US"/>
               <a:t>Second level</a:t>
             </a:r>
           </a:p>
           <a:p>
             <a:pPr lvl="2"/>
             <a:r>
-              <a:rPr lang="en-US" smtClean="0"/>
+              <a:rPr lang="en-US"/>
               <a:t>Third level</a:t>
             </a:r>
           </a:p>
           <a:p>
             <a:pPr lvl="3"/>
             <a:r>
-              <a:rPr lang="en-US" smtClean="0"/>
+              <a:rPr lang="en-US"/>
               <a:t>Fourth level</a:t>
             </a:r>
           </a:p>
           <a:p>
             <a:pPr lvl="4"/>
             <a:r>
-              <a:rPr lang="en-US" smtClean="0"/>
+              <a:rPr lang="en-US"/>
               <a:t>Fifth level</a:t>
             </a:r>
-            <a:endParaRPr lang="en-US"/>
           </a:p>
         </p:txBody>
       </p:sp>
@@ -1350,7 +1354,7 @@
           <a:p>
             <a:fld id="{5BCAD085-E8A6-8845-BD4E-CB4CCA059FC4}" type="datetimeFigureOut">
               <a:rPr lang="en-US" smtClean="0"/>
-              <a:t>1/27/13</a:t>
+              <a:t>6/3/2026</a:t>
             </a:fld>
             <a:endParaRPr lang="en-US"/>
           </a:p>
@@ -1448,10 +1452,9 @@
           </a:lstStyle>
           <a:p>
             <a:r>
-              <a:rPr lang="en-US" smtClean="0"/>
+              <a:rPr lang="en-US"/>
               <a:t>Click to edit Master title style</a:t>
             </a:r>
-            <a:endParaRPr lang="en-US"/>
           </a:p>
         </p:txBody>
       </p:sp>
@@ -1514,7 +1517,7 @@
           <a:p>
             <a:pPr lvl="0"/>
             <a:r>
-              <a:rPr lang="en-US" smtClean="0"/>
+              <a:rPr lang="en-US"/>
               <a:t>Click to edit Master text styles</a:t>
             </a:r>
           </a:p>
@@ -1570,38 +1573,37 @@
           <a:p>
             <a:pPr lvl="0"/>
             <a:r>
-              <a:rPr lang="en-US" smtClean="0"/>
+              <a:rPr lang="en-US"/>
               <a:t>Click to edit Master text styles</a:t>
             </a:r>
           </a:p>
           <a:p>
             <a:pPr lvl="1"/>
             <a:r>
-              <a:rPr lang="en-US" smtClean="0"/>
+              <a:rPr lang="en-US"/>
               <a:t>Second level</a:t>
             </a:r>
           </a:p>
           <a:p>
             <a:pPr lvl="2"/>
             <a:r>
-              <a:rPr lang="en-US" smtClean="0"/>
+              <a:rPr lang="en-US"/>
               <a:t>Third level</a:t>
             </a:r>
           </a:p>
           <a:p>
             <a:pPr lvl="3"/>
             <a:r>
-              <a:rPr lang="en-US" smtClean="0"/>
+              <a:rPr lang="en-US"/>
               <a:t>Fourth level</a:t>
             </a:r>
           </a:p>
           <a:p>
             <a:pPr lvl="4"/>
             <a:r>
-              <a:rPr lang="en-US" smtClean="0"/>
+              <a:rPr lang="en-US"/>
               <a:t>Fifth level</a:t>
             </a:r>
-            <a:endParaRPr lang="en-US"/>
           </a:p>
         </p:txBody>
       </p:sp>
@@ -1664,7 +1666,7 @@
           <a:p>
             <a:pPr lvl="0"/>
             <a:r>
-              <a:rPr lang="en-US" smtClean="0"/>
+              <a:rPr lang="en-US"/>
               <a:t>Click to edit Master text styles</a:t>
             </a:r>
           </a:p>
@@ -1720,38 +1722,37 @@
           <a:p>
             <a:pPr lvl="0"/>
             <a:r>
-              <a:rPr lang="en-US" smtClean="0"/>
+              <a:rPr lang="en-US"/>
               <a:t>Click to edit Master text styles</a:t>
             </a:r>
           </a:p>
           <a:p>
             <a:pPr lvl="1"/>
             <a:r>
-              <a:rPr lang="en-US" smtClean="0"/>
+              <a:rPr lang="en-US"/>
               <a:t>Second level</a:t>
             </a:r>
           </a:p>
           <a:p>
             <a:pPr lvl="2"/>
             <a:r>
-              <a:rPr lang="en-US" smtClean="0"/>
+              <a:rPr lang="en-US"/>
               <a:t>Third level</a:t>
             </a:r>
           </a:p>
           <a:p>
             <a:pPr lvl="3"/>
             <a:r>
-              <a:rPr lang="en-US" smtClean="0"/>
+              <a:rPr lang="en-US"/>
               <a:t>Fourth level</a:t>
             </a:r>
           </a:p>
           <a:p>
             <a:pPr lvl="4"/>
             <a:r>
-              <a:rPr lang="en-US" smtClean="0"/>
+              <a:rPr lang="en-US"/>
               <a:t>Fifth level</a:t>
             </a:r>
-            <a:endParaRPr lang="en-US"/>
           </a:p>
         </p:txBody>
       </p:sp>
@@ -1772,7 +1773,7 @@
           <a:p>
             <a:fld id="{5BCAD085-E8A6-8845-BD4E-CB4CCA059FC4}" type="datetimeFigureOut">
               <a:rPr lang="en-US" smtClean="0"/>
-              <a:t>1/27/13</a:t>
+              <a:t>6/3/2026</a:t>
             </a:fld>
             <a:endParaRPr lang="en-US"/>
           </a:p>
@@ -1866,10 +1867,9 @@
           <a:lstStyle/>
           <a:p>
             <a:r>
-              <a:rPr lang="en-US" smtClean="0"/>
+              <a:rPr lang="en-US"/>
               <a:t>Click to edit Master title style</a:t>
             </a:r>
-            <a:endParaRPr lang="en-US"/>
           </a:p>
         </p:txBody>
       </p:sp>
@@ -1890,7 +1890,7 @@
           <a:p>
             <a:fld id="{5BCAD085-E8A6-8845-BD4E-CB4CCA059FC4}" type="datetimeFigureOut">
               <a:rPr lang="en-US" smtClean="0"/>
-              <a:t>1/27/13</a:t>
+              <a:t>6/3/2026</a:t>
             </a:fld>
             <a:endParaRPr lang="en-US"/>
           </a:p>
@@ -1985,7 +1985,7 @@
           <a:p>
             <a:fld id="{5BCAD085-E8A6-8845-BD4E-CB4CCA059FC4}" type="datetimeFigureOut">
               <a:rPr lang="en-US" smtClean="0"/>
-              <a:t>1/27/13</a:t>
+              <a:t>6/3/2026</a:t>
             </a:fld>
             <a:endParaRPr lang="en-US"/>
           </a:p>
@@ -2088,10 +2088,9 @@
           </a:lstStyle>
           <a:p>
             <a:r>
-              <a:rPr lang="en-US" smtClean="0"/>
+              <a:rPr lang="en-US"/>
               <a:t>Click to edit Master title style</a:t>
             </a:r>
-            <a:endParaRPr lang="en-US"/>
           </a:p>
         </p:txBody>
       </p:sp>
@@ -2145,38 +2144,37 @@
           <a:p>
             <a:pPr lvl="0"/>
             <a:r>
-              <a:rPr lang="en-US" smtClean="0"/>
+              <a:rPr lang="en-US"/>
               <a:t>Click to edit Master text styles</a:t>
             </a:r>
           </a:p>
           <a:p>
             <a:pPr lvl="1"/>
             <a:r>
-              <a:rPr lang="en-US" smtClean="0"/>
+              <a:rPr lang="en-US"/>
               <a:t>Second level</a:t>
             </a:r>
           </a:p>
           <a:p>
             <a:pPr lvl="2"/>
             <a:r>
-              <a:rPr lang="en-US" smtClean="0"/>
+              <a:rPr lang="en-US"/>
               <a:t>Third level</a:t>
             </a:r>
           </a:p>
           <a:p>
             <a:pPr lvl="3"/>
             <a:r>
-              <a:rPr lang="en-US" smtClean="0"/>
+              <a:rPr lang="en-US"/>
               <a:t>Fourth level</a:t>
             </a:r>
           </a:p>
           <a:p>
             <a:pPr lvl="4"/>
             <a:r>
-              <a:rPr lang="en-US" smtClean="0"/>
+              <a:rPr lang="en-US"/>
               <a:t>Fifth level</a:t>
             </a:r>
-            <a:endParaRPr lang="en-US"/>
           </a:p>
         </p:txBody>
       </p:sp>
@@ -2239,7 +2237,7 @@
           <a:p>
             <a:pPr lvl="0"/>
             <a:r>
-              <a:rPr lang="en-US" smtClean="0"/>
+              <a:rPr lang="en-US"/>
               <a:t>Click to edit Master text styles</a:t>
             </a:r>
           </a:p>
@@ -2262,7 +2260,7 @@
           <a:p>
             <a:fld id="{5BCAD085-E8A6-8845-BD4E-CB4CCA059FC4}" type="datetimeFigureOut">
               <a:rPr lang="en-US" smtClean="0"/>
-              <a:t>1/27/13</a:t>
+              <a:t>6/3/2026</a:t>
             </a:fld>
             <a:endParaRPr lang="en-US"/>
           </a:p>
@@ -2365,10 +2363,9 @@
           </a:lstStyle>
           <a:p>
             <a:r>
-              <a:rPr lang="en-US" smtClean="0"/>
+              <a:rPr lang="en-US"/>
               <a:t>Click to edit Master title style</a:t>
             </a:r>
-            <a:endParaRPr lang="en-US"/>
           </a:p>
         </p:txBody>
       </p:sp>
@@ -2492,7 +2489,7 @@
           <a:p>
             <a:pPr lvl="0"/>
             <a:r>
-              <a:rPr lang="en-US" smtClean="0"/>
+              <a:rPr lang="en-US"/>
               <a:t>Click to edit Master text styles</a:t>
             </a:r>
           </a:p>
@@ -2515,7 +2512,7 @@
           <a:p>
             <a:fld id="{5BCAD085-E8A6-8845-BD4E-CB4CCA059FC4}" type="datetimeFigureOut">
               <a:rPr lang="en-US" smtClean="0"/>
-              <a:t>1/27/13</a:t>
+              <a:t>6/3/2026</a:t>
             </a:fld>
             <a:endParaRPr lang="en-US"/>
           </a:p>
@@ -2624,10 +2621,9 @@
           <a:lstStyle/>
           <a:p>
             <a:r>
-              <a:rPr lang="en-US" smtClean="0"/>
+              <a:rPr lang="en-US"/>
               <a:t>Click to edit Master title style</a:t>
             </a:r>
-            <a:endParaRPr lang="en-US"/>
           </a:p>
         </p:txBody>
       </p:sp>
@@ -2658,38 +2654,37 @@
           <a:p>
             <a:pPr lvl="0"/>
             <a:r>
-              <a:rPr lang="en-US" smtClean="0"/>
+              <a:rPr lang="en-US"/>
               <a:t>Click to edit Master text styles</a:t>
             </a:r>
           </a:p>
           <a:p>
             <a:pPr lvl="1"/>
             <a:r>
-              <a:rPr lang="en-US" smtClean="0"/>
+              <a:rPr lang="en-US"/>
               <a:t>Second level</a:t>
             </a:r>
           </a:p>
           <a:p>
             <a:pPr lvl="2"/>
             <a:r>
-              <a:rPr lang="en-US" smtClean="0"/>
+              <a:rPr lang="en-US"/>
               <a:t>Third level</a:t>
             </a:r>
           </a:p>
           <a:p>
             <a:pPr lvl="3"/>
             <a:r>
-              <a:rPr lang="en-US" smtClean="0"/>
+              <a:rPr lang="en-US"/>
               <a:t>Fourth level</a:t>
             </a:r>
           </a:p>
           <a:p>
             <a:pPr lvl="4"/>
             <a:r>
-              <a:rPr lang="en-US" smtClean="0"/>
+              <a:rPr lang="en-US"/>
               <a:t>Fifth level</a:t>
             </a:r>
-            <a:endParaRPr lang="en-US"/>
           </a:p>
         </p:txBody>
       </p:sp>
@@ -2728,7 +2723,7 @@
           <a:p>
             <a:fld id="{5BCAD085-E8A6-8845-BD4E-CB4CCA059FC4}" type="datetimeFigureOut">
               <a:rPr lang="en-US" smtClean="0"/>
-              <a:t>1/27/13</a:t>
+              <a:t>6/3/2026</a:t>
             </a:fld>
             <a:endParaRPr lang="en-US"/>
           </a:p>
@@ -3087,7 +3082,7 @@
 </file>
 
 <file path=ppt/slides/slide1.xml><?xml version="1.0" encoding="utf-8"?>
-<p:sld xmlns:a="http://schemas.openxmlformats.org/drawingml/2006/main" xmlns:p="http://schemas.openxmlformats.org/presentationml/2006/main" xmlns:r="http://schemas.openxmlformats.org/officeDocument/2006/relationships">
+<p:sld xmlns:a="http://schemas.openxmlformats.org/drawingml/2006/main" xmlns:r="http://schemas.openxmlformats.org/officeDocument/2006/relationships" xmlns:p="http://schemas.openxmlformats.org/presentationml/2006/main">
   <p:cSld>
     <p:bg>
       <p:bgPr>
@@ -3103,7 +3098,14 @@
         <p:cNvGrpSpPr/>
         <p:nvPr/>
       </p:nvGrpSpPr>
-      <p:grpSpPr/>
+      <p:grpSpPr>
+        <a:xfrm>
+          <a:off x="0" y="0"/>
+          <a:ext cx="0" cy="0"/>
+          <a:chOff x="0" y="0"/>
+          <a:chExt cx="0" cy="0"/>
+        </a:xfrm>
+      </p:grpSpPr>
       <p:sp>
         <p:nvSpPr>
           <p:cNvPr id="2" name="Rectangle 1"/>
@@ -3144,6 +3146,7 @@
           <a:lstStyle/>
           <a:p>
             <a:pPr algn="ctr"/>
+            <a:endParaRPr/>
           </a:p>
         </p:txBody>
       </p:sp>
@@ -3187,6 +3190,7 @@
           <a:lstStyle/>
           <a:p>
             <a:pPr algn="ctr"/>
+            <a:endParaRPr/>
           </a:p>
         </p:txBody>
       </p:sp>
@@ -3588,7 +3592,7 @@
 </file>
 
 <file path=ppt/slides/slide2.xml><?xml version="1.0" encoding="utf-8"?>
-<p:sld xmlns:a="http://schemas.openxmlformats.org/drawingml/2006/main" xmlns:p="http://schemas.openxmlformats.org/presentationml/2006/main" xmlns:r="http://schemas.openxmlformats.org/officeDocument/2006/relationships">
+<p:sld xmlns:a="http://schemas.openxmlformats.org/drawingml/2006/main" xmlns:r="http://schemas.openxmlformats.org/officeDocument/2006/relationships" xmlns:p="http://schemas.openxmlformats.org/presentationml/2006/main">
   <p:cSld>
     <p:bg>
       <p:bgPr>
@@ -3604,7 +3608,14 @@
         <p:cNvGrpSpPr/>
         <p:nvPr/>
       </p:nvGrpSpPr>
-      <p:grpSpPr/>
+      <p:grpSpPr>
+        <a:xfrm>
+          <a:off x="0" y="0"/>
+          <a:ext cx="0" cy="0"/>
+          <a:chOff x="0" y="0"/>
+          <a:chExt cx="0" cy="0"/>
+        </a:xfrm>
+      </p:grpSpPr>
       <p:sp>
         <p:nvSpPr>
           <p:cNvPr id="2" name="Rectangle 1"/>
@@ -3645,6 +3656,7 @@
           <a:lstStyle/>
           <a:p>
             <a:pPr algn="ctr"/>
+            <a:endParaRPr/>
           </a:p>
         </p:txBody>
       </p:sp>
@@ -3684,7 +3696,7 @@
           </a:fontRef>
         </p:style>
         <p:txBody>
-          <a:bodyPr rtlCol="0" anchor="ctr" wrap="none"/>
+          <a:bodyPr wrap="none" rtlCol="0" anchor="ctr"/>
           <a:lstStyle/>
           <a:p>
             <a:pPr algn="ctr"/>
@@ -3962,6 +3974,7 @@
           <a:lstStyle/>
           <a:p>
             <a:pPr algn="ctr"/>
+            <a:endParaRPr/>
           </a:p>
         </p:txBody>
       </p:sp>
@@ -4189,7 +4202,7 @@
 </file>
 
 <file path=ppt/slides/slide3.xml><?xml version="1.0" encoding="utf-8"?>
-<p:sld xmlns:a="http://schemas.openxmlformats.org/drawingml/2006/main" xmlns:p="http://schemas.openxmlformats.org/presentationml/2006/main" xmlns:r="http://schemas.openxmlformats.org/officeDocument/2006/relationships">
+<p:sld xmlns:a="http://schemas.openxmlformats.org/drawingml/2006/main" xmlns:r="http://schemas.openxmlformats.org/officeDocument/2006/relationships" xmlns:p="http://schemas.openxmlformats.org/presentationml/2006/main">
   <p:cSld>
     <p:bg>
       <p:bgPr>
@@ -4205,7 +4218,14 @@
         <p:cNvGrpSpPr/>
         <p:nvPr/>
       </p:nvGrpSpPr>
-      <p:grpSpPr/>
+      <p:grpSpPr>
+        <a:xfrm>
+          <a:off x="0" y="0"/>
+          <a:ext cx="0" cy="0"/>
+          <a:chOff x="0" y="0"/>
+          <a:chExt cx="0" cy="0"/>
+        </a:xfrm>
+      </p:grpSpPr>
       <p:sp>
         <p:nvSpPr>
           <p:cNvPr id="2" name="Rectangle 1"/>
@@ -4246,6 +4266,7 @@
           <a:lstStyle/>
           <a:p>
             <a:pPr algn="ctr"/>
+            <a:endParaRPr/>
           </a:p>
         </p:txBody>
       </p:sp>
@@ -4285,7 +4306,7 @@
           </a:fontRef>
         </p:style>
         <p:txBody>
-          <a:bodyPr rtlCol="0" anchor="ctr" wrap="none"/>
+          <a:bodyPr wrap="none" rtlCol="0" anchor="ctr"/>
           <a:lstStyle/>
           <a:p>
             <a:pPr algn="ctr"/>
@@ -4377,6 +4398,7 @@
           <a:lstStyle/>
           <a:p>
             <a:pPr algn="ctr"/>
+            <a:endParaRPr/>
           </a:p>
         </p:txBody>
       </p:sp>
@@ -4457,6 +4479,7 @@
           <a:lstStyle/>
           <a:p>
             <a:pPr algn="ctr"/>
+            <a:endParaRPr/>
           </a:p>
         </p:txBody>
       </p:sp>
@@ -4609,6 +4632,7 @@
           <a:lstStyle/>
           <a:p>
             <a:pPr algn="ctr"/>
+            <a:endParaRPr/>
           </a:p>
         </p:txBody>
       </p:sp>
@@ -4761,6 +4785,7 @@
           <a:lstStyle/>
           <a:p>
             <a:pPr algn="ctr"/>
+            <a:endParaRPr/>
           </a:p>
         </p:txBody>
       </p:sp>
@@ -4985,7 +5010,7 @@
 </file>
 
 <file path=ppt/slides/slide4.xml><?xml version="1.0" encoding="utf-8"?>
-<p:sld xmlns:a="http://schemas.openxmlformats.org/drawingml/2006/main" xmlns:p="http://schemas.openxmlformats.org/presentationml/2006/main" xmlns:r="http://schemas.openxmlformats.org/officeDocument/2006/relationships">
+<p:sld xmlns:a="http://schemas.openxmlformats.org/drawingml/2006/main" xmlns:r="http://schemas.openxmlformats.org/officeDocument/2006/relationships" xmlns:p="http://schemas.openxmlformats.org/presentationml/2006/main">
   <p:cSld>
     <p:bg>
       <p:bgPr>
@@ -5001,7 +5026,14 @@
         <p:cNvGrpSpPr/>
         <p:nvPr/>
       </p:nvGrpSpPr>
-      <p:grpSpPr/>
+      <p:grpSpPr>
+        <a:xfrm>
+          <a:off x="0" y="0"/>
+          <a:ext cx="0" cy="0"/>
+          <a:chOff x="0" y="0"/>
+          <a:chExt cx="0" cy="0"/>
+        </a:xfrm>
+      </p:grpSpPr>
       <p:sp>
         <p:nvSpPr>
           <p:cNvPr id="2" name="Rectangle 1"/>
@@ -5042,6 +5074,7 @@
           <a:lstStyle/>
           <a:p>
             <a:pPr algn="ctr"/>
+            <a:endParaRPr/>
           </a:p>
         </p:txBody>
       </p:sp>
@@ -5081,7 +5114,7 @@
           </a:fontRef>
         </p:style>
         <p:txBody>
-          <a:bodyPr rtlCol="0" anchor="ctr" wrap="none"/>
+          <a:bodyPr wrap="none" rtlCol="0" anchor="ctr"/>
           <a:lstStyle/>
           <a:p>
             <a:pPr algn="ctr"/>
@@ -5368,6 +5401,7 @@
           <a:lstStyle/>
           <a:p>
             <a:pPr algn="ctr"/>
+            <a:endParaRPr/>
           </a:p>
         </p:txBody>
       </p:sp>
@@ -5561,7 +5595,7 @@
 </file>
 
 <file path=ppt/slides/slide5.xml><?xml version="1.0" encoding="utf-8"?>
-<p:sld xmlns:a="http://schemas.openxmlformats.org/drawingml/2006/main" xmlns:p="http://schemas.openxmlformats.org/presentationml/2006/main" xmlns:r="http://schemas.openxmlformats.org/officeDocument/2006/relationships">
+<p:sld xmlns:a="http://schemas.openxmlformats.org/drawingml/2006/main" xmlns:r="http://schemas.openxmlformats.org/officeDocument/2006/relationships" xmlns:p="http://schemas.openxmlformats.org/presentationml/2006/main">
   <p:cSld>
     <p:bg>
       <p:bgPr>
@@ -5577,7 +5611,14 @@
         <p:cNvGrpSpPr/>
         <p:nvPr/>
       </p:nvGrpSpPr>
-      <p:grpSpPr/>
+      <p:grpSpPr>
+        <a:xfrm>
+          <a:off x="0" y="0"/>
+          <a:ext cx="0" cy="0"/>
+          <a:chOff x="0" y="0"/>
+          <a:chExt cx="0" cy="0"/>
+        </a:xfrm>
+      </p:grpSpPr>
       <p:sp>
         <p:nvSpPr>
           <p:cNvPr id="2" name="Rectangle 1"/>
@@ -5618,6 +5659,7 @@
           <a:lstStyle/>
           <a:p>
             <a:pPr algn="ctr"/>
+            <a:endParaRPr/>
           </a:p>
         </p:txBody>
       </p:sp>
@@ -5657,7 +5699,7 @@
           </a:fontRef>
         </p:style>
         <p:txBody>
-          <a:bodyPr rtlCol="0" anchor="ctr" wrap="none"/>
+          <a:bodyPr wrap="none" rtlCol="0" anchor="ctr"/>
           <a:lstStyle/>
           <a:p>
             <a:pPr algn="ctr"/>
@@ -5944,6 +5986,7 @@
           <a:lstStyle/>
           <a:p>
             <a:pPr algn="ctr"/>
+            <a:endParaRPr/>
           </a:p>
         </p:txBody>
       </p:sp>
@@ -6136,7 +6179,7 @@
 </file>
 
 <file path=ppt/slides/slide6.xml><?xml version="1.0" encoding="utf-8"?>
-<p:sld xmlns:a="http://schemas.openxmlformats.org/drawingml/2006/main" xmlns:p="http://schemas.openxmlformats.org/presentationml/2006/main" xmlns:r="http://schemas.openxmlformats.org/officeDocument/2006/relationships">
+<p:sld xmlns:a="http://schemas.openxmlformats.org/drawingml/2006/main" xmlns:r="http://schemas.openxmlformats.org/officeDocument/2006/relationships" xmlns:p="http://schemas.openxmlformats.org/presentationml/2006/main">
   <p:cSld>
     <p:bg>
       <p:bgPr>
@@ -6152,7 +6195,14 @@
         <p:cNvGrpSpPr/>
         <p:nvPr/>
       </p:nvGrpSpPr>
-      <p:grpSpPr/>
+      <p:grpSpPr>
+        <a:xfrm>
+          <a:off x="0" y="0"/>
+          <a:ext cx="0" cy="0"/>
+          <a:chOff x="0" y="0"/>
+          <a:chExt cx="0" cy="0"/>
+        </a:xfrm>
+      </p:grpSpPr>
       <p:sp>
         <p:nvSpPr>
           <p:cNvPr id="2" name="Rectangle 1"/>
@@ -6193,6 +6243,7 @@
           <a:lstStyle/>
           <a:p>
             <a:pPr algn="ctr"/>
+            <a:endParaRPr/>
           </a:p>
         </p:txBody>
       </p:sp>
@@ -6232,7 +6283,7 @@
           </a:fontRef>
         </p:style>
         <p:txBody>
-          <a:bodyPr rtlCol="0" anchor="ctr" wrap="none"/>
+          <a:bodyPr wrap="none" rtlCol="0" anchor="ctr"/>
           <a:lstStyle/>
           <a:p>
             <a:pPr algn="ctr"/>
@@ -6519,6 +6570,7 @@
           <a:lstStyle/>
           <a:p>
             <a:pPr algn="ctr"/>
+            <a:endParaRPr/>
           </a:p>
         </p:txBody>
       </p:sp>
@@ -6711,7 +6763,7 @@
 </file>
 
 <file path=ppt/slides/slide7.xml><?xml version="1.0" encoding="utf-8"?>
-<p:sld xmlns:a="http://schemas.openxmlformats.org/drawingml/2006/main" xmlns:p="http://schemas.openxmlformats.org/presentationml/2006/main" xmlns:r="http://schemas.openxmlformats.org/officeDocument/2006/relationships">
+<p:sld xmlns:a="http://schemas.openxmlformats.org/drawingml/2006/main" xmlns:r="http://schemas.openxmlformats.org/officeDocument/2006/relationships" xmlns:p="http://schemas.openxmlformats.org/presentationml/2006/main">
   <p:cSld>
     <p:bg>
       <p:bgPr>
@@ -6727,7 +6779,14 @@
         <p:cNvGrpSpPr/>
         <p:nvPr/>
       </p:nvGrpSpPr>
-      <p:grpSpPr/>
+      <p:grpSpPr>
+        <a:xfrm>
+          <a:off x="0" y="0"/>
+          <a:ext cx="0" cy="0"/>
+          <a:chOff x="0" y="0"/>
+          <a:chExt cx="0" cy="0"/>
+        </a:xfrm>
+      </p:grpSpPr>
       <p:sp>
         <p:nvSpPr>
           <p:cNvPr id="2" name="Rectangle 1"/>
@@ -6768,6 +6827,7 @@
           <a:lstStyle/>
           <a:p>
             <a:pPr algn="ctr"/>
+            <a:endParaRPr/>
           </a:p>
         </p:txBody>
       </p:sp>
@@ -6807,7 +6867,7 @@
           </a:fontRef>
         </p:style>
         <p:txBody>
-          <a:bodyPr rtlCol="0" anchor="ctr" wrap="none"/>
+          <a:bodyPr wrap="none" rtlCol="0" anchor="ctr"/>
           <a:lstStyle/>
           <a:p>
             <a:pPr algn="ctr"/>
@@ -6901,6 +6961,7 @@
           <a:lstStyle/>
           <a:p>
             <a:pPr algn="ctr"/>
+            <a:endParaRPr/>
           </a:p>
         </p:txBody>
       </p:sp>
@@ -7104,6 +7165,7 @@
           <a:lstStyle/>
           <a:p>
             <a:pPr algn="ctr"/>
+            <a:endParaRPr/>
           </a:p>
         </p:txBody>
       </p:sp>
@@ -7344,7 +7406,7 @@
 </file>
 
 <file path=ppt/slides/slide8.xml><?xml version="1.0" encoding="utf-8"?>
-<p:sld xmlns:a="http://schemas.openxmlformats.org/drawingml/2006/main" xmlns:p="http://schemas.openxmlformats.org/presentationml/2006/main" xmlns:r="http://schemas.openxmlformats.org/officeDocument/2006/relationships">
+<p:sld xmlns:a="http://schemas.openxmlformats.org/drawingml/2006/main" xmlns:r="http://schemas.openxmlformats.org/officeDocument/2006/relationships" xmlns:p="http://schemas.openxmlformats.org/presentationml/2006/main">
   <p:cSld>
     <p:bg>
       <p:bgPr>
@@ -7360,7 +7422,14 @@
         <p:cNvGrpSpPr/>
         <p:nvPr/>
       </p:nvGrpSpPr>
-      <p:grpSpPr/>
+      <p:grpSpPr>
+        <a:xfrm>
+          <a:off x="0" y="0"/>
+          <a:ext cx="0" cy="0"/>
+          <a:chOff x="0" y="0"/>
+          <a:chExt cx="0" cy="0"/>
+        </a:xfrm>
+      </p:grpSpPr>
       <p:sp>
         <p:nvSpPr>
           <p:cNvPr id="2" name="Rectangle 1"/>
@@ -7401,6 +7470,7 @@
           <a:lstStyle/>
           <a:p>
             <a:pPr algn="ctr"/>
+            <a:endParaRPr/>
           </a:p>
         </p:txBody>
       </p:sp>
@@ -7440,7 +7510,7 @@
           </a:fontRef>
         </p:style>
         <p:txBody>
-          <a:bodyPr rtlCol="0" anchor="ctr" wrap="none"/>
+          <a:bodyPr wrap="none" rtlCol="0" anchor="ctr"/>
           <a:lstStyle/>
           <a:p>
             <a:pPr algn="ctr"/>
@@ -7531,6 +7601,7 @@
           <a:lstStyle/>
           <a:p>
             <a:pPr algn="ctr"/>
+            <a:endParaRPr/>
           </a:p>
         </p:txBody>
       </p:sp>
@@ -7644,6 +7715,7 @@
           <a:lstStyle/>
           <a:p>
             <a:pPr algn="ctr"/>
+            <a:endParaRPr/>
           </a:p>
         </p:txBody>
       </p:sp>
@@ -7757,6 +7829,7 @@
           <a:lstStyle/>
           <a:p>
             <a:pPr algn="ctr"/>
+            <a:endParaRPr/>
           </a:p>
         </p:txBody>
       </p:sp>
@@ -7870,6 +7943,7 @@
           <a:lstStyle/>
           <a:p>
             <a:pPr algn="ctr"/>
+            <a:endParaRPr/>
           </a:p>
         </p:txBody>
       </p:sp>
@@ -7983,6 +8057,7 @@
           <a:lstStyle/>
           <a:p>
             <a:pPr algn="ctr"/>
+            <a:endParaRPr/>
           </a:p>
         </p:txBody>
       </p:sp>
@@ -8096,6 +8171,7 @@
           <a:lstStyle/>
           <a:p>
             <a:pPr algn="ctr"/>
+            <a:endParaRPr/>
           </a:p>
         </p:txBody>
       </p:sp>
@@ -8211,6 +8287,7 @@
           <a:lstStyle/>
           <a:p>
             <a:pPr algn="ctr"/>
+            <a:endParaRPr/>
           </a:p>
         </p:txBody>
       </p:sp>
@@ -8491,7 +8568,7 @@
 </file>
 
 <file path=ppt/slides/slide9.xml><?xml version="1.0" encoding="utf-8"?>
-<p:sld xmlns:a="http://schemas.openxmlformats.org/drawingml/2006/main" xmlns:p="http://schemas.openxmlformats.org/presentationml/2006/main" xmlns:r="http://schemas.openxmlformats.org/officeDocument/2006/relationships">
+<p:sld xmlns:a="http://schemas.openxmlformats.org/drawingml/2006/main" xmlns:r="http://schemas.openxmlformats.org/officeDocument/2006/relationships" xmlns:p="http://schemas.openxmlformats.org/presentationml/2006/main">
   <p:cSld>
     <p:bg>
       <p:bgPr>
@@ -8507,7 +8584,14 @@
         <p:cNvGrpSpPr/>
         <p:nvPr/>
       </p:nvGrpSpPr>
-      <p:grpSpPr/>
+      <p:grpSpPr>
+        <a:xfrm>
+          <a:off x="0" y="0"/>
+          <a:ext cx="0" cy="0"/>
+          <a:chOff x="0" y="0"/>
+          <a:chExt cx="0" cy="0"/>
+        </a:xfrm>
+      </p:grpSpPr>
       <p:sp>
         <p:nvSpPr>
           <p:cNvPr id="2" name="TextBox 1"/>
@@ -8621,6 +8705,7 @@
           <a:lstStyle/>
           <a:p>
             <a:pPr algn="ctr"/>
+            <a:endParaRPr/>
           </a:p>
         </p:txBody>
       </p:sp>
@@ -8737,6 +8822,7 @@
           <a:lstStyle/>
           <a:p>
             <a:pPr algn="ctr"/>
+            <a:endParaRPr/>
           </a:p>
         </p:txBody>
       </p:sp>
@@ -8853,6 +8939,7 @@
           <a:lstStyle/>
           <a:p>
             <a:pPr algn="ctr"/>
+            <a:endParaRPr/>
           </a:p>
         </p:txBody>
       </p:sp>
@@ -8936,7 +9023,7 @@
         <p:spPr>
           <a:xfrm>
             <a:off x="914400" y="5669280"/>
-            <a:ext cx="10332720" cy="457200"/>
+            <a:ext cx="10332720" cy="292388"/>
           </a:xfrm>
           <a:prstGeom prst="rect">
             <a:avLst/>
@@ -8951,13 +9038,13 @@
           <a:p>
             <a:pPr algn="ctr"/>
             <a:r>
-              <a:rPr sz="1300" b="0">
+              <a:rPr sz="1300" b="0" dirty="0">
                 <a:solidFill>
                   <a:srgbClr val="A0D0CC"/>
                 </a:solidFill>
                 <a:latin typeface="Calibri"/>
               </a:rPr>
-              <a:t>3 live agents  ·  Shared evidence layer  ·  AI + deterministic hybrid  ·  Ready for production</a:t>
+              <a:t>3 live agents  ·  Shared evidence layer  ·  AI + deterministic hybrid  </a:t>
             </a:r>
           </a:p>
         </p:txBody>

</xml_diff>